<commit_message>
Met a jour presentation EHPAD Monitor
</commit_message>
<xml_diff>
--- a/EHPAD_Monitor.pptx
+++ b/EHPAD_Monitor.pptx
@@ -1993,7 +1993,7 @@
                 <a:ea typeface="Calibri" pitchFamily="34" charset="-122"/>
                 <a:cs typeface="Calibri" pitchFamily="34" charset="-120"/>
               </a:rPr>
-              <a:t>Surveillance temps réel · 25 résidents · 7 agents A2A · 3 LLM · Pipeline IoT bout-en-bout</a:t>
+              <a:t>Surveillance temps réel · 25 résidents · ML 30-60 min · LLM local optionnel · Pipeline IoT bout-en-bout</a:t>
             </a:r>
             <a:endParaRPr lang="en-US" sz="1300" dirty="0"/>
           </a:p>
@@ -2363,7 +2363,7 @@
                 <a:ea typeface="Calibri" pitchFamily="34" charset="-122"/>
                 <a:cs typeface="Calibri" pitchFamily="34" charset="-120"/>
               </a:rPr>
-              <a:t>LLM routés</a:t>
+              <a:t>LLM local</a:t>
             </a:r>
             <a:endParaRPr lang="en-US" sz="900" dirty="0"/>
           </a:p>
@@ -2380,7 +2380,7 @@
                 <a:ea typeface="Calibri" pitchFamily="34" charset="-122"/>
                 <a:cs typeface="Calibri" pitchFamily="34" charset="-120"/>
               </a:rPr>
-              <a:t>par tâche</a:t>
+              <a:t>optionnel</a:t>
             </a:r>
             <a:endParaRPr lang="en-US" sz="900" dirty="0"/>
           </a:p>
@@ -3131,7 +3131,7 @@
                 <a:ea typeface="Calibri" pitchFamily="34" charset="-122"/>
                 <a:cs typeface="Calibri" pitchFamily="34" charset="-120"/>
               </a:rPr>
-              <a:t>LLM routés par tâche</a:t>
+              <a:t>Synthèse locale optionnelle</a:t>
             </a:r>
             <a:endParaRPr lang="en-US" sz="1100" dirty="0"/>
           </a:p>
@@ -3170,7 +3170,7 @@
                 <a:ea typeface="Calibri" pitchFamily="34" charset="-122"/>
                 <a:cs typeface="Calibri" pitchFamily="34" charset="-120"/>
               </a:rPr>
-              <a:t>Llama 3.2 résumés rapides · Qwen 2.5 JSON structuré · Meditron rapport médical quotidien</a:t>
+              <a:t>Ollama optionnel : résumé soignant, message famille, rapport quotidien</a:t>
             </a:r>
             <a:endParaRPr lang="en-US" sz="900" dirty="0"/>
           </a:p>
@@ -3902,7 +3902,7 @@
                 <a:ea typeface="Calibri" pitchFamily="34" charset="-122"/>
                 <a:cs typeface="Calibri" pitchFamily="34" charset="-120"/>
               </a:rPr>
-              <a:t>MQTT TLS + ACL · ports restreints 127.0.0.1 · Redis lock · VAPID externalisé · bcrypt passwords</a:t>
+              <a:t>MQTT auth + ACL · ports restreints 127.0.0.1 · Redis lock · VAPID externalisé · bcrypt passwords</a:t>
             </a:r>
             <a:endParaRPr lang="en-US" sz="900" dirty="0"/>
           </a:p>
@@ -4146,7 +4146,7 @@
                 <a:ea typeface="Calibri" pitchFamily="34" charset="-122"/>
                 <a:cs typeface="Calibri" pitchFamily="34" charset="-120"/>
               </a:rPr>
-              <a:t>DailyReportService · fiche transmission structurée · export quotidien par résident · rétention 365j</a:t>
+              <a:t>DailyReportService · fiche transmission · benchmark scalabilité · guide de démonstration</a:t>
             </a:r>
             <a:endParaRPr lang="en-US" sz="900" dirty="0"/>
           </a:p>
@@ -7233,7 +7233,7 @@
                 <a:ea typeface="Calibri" pitchFamily="34" charset="-122"/>
                 <a:cs typeface="Calibri" pitchFamily="34" charset="-120"/>
               </a:rPr>
-              <a:t>Routing par tâche : Llama 3.2 (rapide) · Qwen 2.5 (JSON) · Meditron (médical)</a:t>
+              <a:t>LLM local optionnel : résumé, JSON, rapport. Décision côté règles/KB + ML.</a:t>
             </a:r>
             <a:endParaRPr lang="en-US" sz="900" dirty="0"/>
           </a:p>
@@ -8394,7 +8394,7 @@
                 <a:ea typeface="Calibri" pitchFamily="34" charset="-122"/>
                 <a:cs typeface="Calibri" pitchFamily="34" charset="-120"/>
               </a:rPr>
-              <a:t>MQTT allow_anonymous false + TLS en prod</a:t>
+              <a:t>MQTT allow_anonymous false + TLS 8883 en prod</a:t>
             </a:r>
             <a:endParaRPr lang="en-US" sz="900" dirty="0"/>
           </a:p>
@@ -8465,7 +8465,7 @@
                 <a:ea typeface="Calibri" pitchFamily="34" charset="-122"/>
                 <a:cs typeface="Calibri" pitchFamily="34" charset="-120"/>
               </a:rPr>
-              <a:t>APIRouter par domaine (réduction main.py 3000 → 150 lignes)</a:t>
+              <a:t>APIRouter par domaine (main.py ≈ 1044 lignes → objectif &lt; 300)</a:t>
             </a:r>
             <a:endParaRPr lang="en-US" sz="900" dirty="0"/>
           </a:p>
@@ -10069,7 +10069,7 @@
                 <a:ea typeface="Calibri" pitchFamily="34" charset="-122"/>
                 <a:cs typeface="Calibri" pitchFamily="34" charset="-120"/>
               </a:rPr>
-              <a:t>8 services · lancement en une commande</a:t>
+              <a:t>7 services Compose + Ollama optionnel · lancement simple</a:t>
             </a:r>
             <a:endParaRPr lang="en-US" sz="900" dirty="0"/>
           </a:p>
@@ -10366,7 +10366,7 @@
                 <a:ea typeface="Calibri" pitchFamily="34" charset="-122"/>
                 <a:cs typeface="Calibri" pitchFamily="34" charset="-120"/>
               </a:rPr>
-              <a:t>3 LLM routés</a:t>
+              <a:t>LLM optionnel</a:t>
             </a:r>
             <a:endParaRPr lang="en-US" sz="1050" dirty="0"/>
           </a:p>
@@ -10405,7 +10405,7 @@
                 <a:ea typeface="Calibri" pitchFamily="34" charset="-122"/>
                 <a:cs typeface="Calibri" pitchFamily="34" charset="-120"/>
               </a:rPr>
-              <a:t>Llama 3.2 · Qwen 2.5 · Meditron — tâche adaptée</a:t>
+              <a:t>Ollama local — résumé, JSON, rapport quotidien</a:t>
             </a:r>
             <a:endParaRPr lang="en-US" sz="900" dirty="0"/>
           </a:p>
@@ -10517,7 +10517,7 @@
                 <a:ea typeface="Calibri" pitchFamily="34" charset="-122"/>
                 <a:cs typeface="Calibri" pitchFamily="34" charset="-120"/>
               </a:rPr>
-              <a:t>MQTT TLS · ACL · ports restreints · Redis lock</a:t>
+              <a:t>MQTT auth · ACL · ports restreints · Redis lock</a:t>
             </a:r>
             <a:endParaRPr lang="en-US" sz="900" dirty="0"/>
           </a:p>
@@ -10853,7 +10853,7 @@
                 <a:ea typeface="Calibri" pitchFamily="34" charset="-122"/>
                 <a:cs typeface="Calibri" pitchFamily="34" charset="-120"/>
               </a:rPr>
-              <a:t>LLM</a:t>
+              <a:t>usages</a:t>
             </a:r>
             <a:endParaRPr lang="en-US" sz="850" dirty="0"/>
           </a:p>
@@ -11021,6 +11021,14 @@
 <file path=ppt/slides/slide15.xml><?xml version="1.0" encoding="utf-8"?>
 <p:sld xmlns:a="http://schemas.openxmlformats.org/drawingml/2006/main" xmlns:r="http://schemas.openxmlformats.org/officeDocument/2006/relationships" xmlns:p="http://schemas.openxmlformats.org/presentationml/2006/main">
   <p:cSld>
+    <p:bg>
+      <p:bgPr>
+        <a:solidFill>
+          <a:srgbClr val="FFFFFF"/>
+        </a:solidFill>
+        <a:effectLst/>
+      </p:bgPr>
+    </p:bg>
     <p:spTree>
       <p:nvGrpSpPr>
         <p:cNvPr id="1" name=""/>
@@ -11035,6 +11043,2033 @@
           <a:chExt cx="0" cy="0"/>
         </a:xfrm>
       </p:grpSpPr>
+      <p:sp>
+        <p:nvSpPr>
+          <p:cNvPr id="2" name="Rectangle 1"/>
+          <p:cNvSpPr/>
+          <p:nvPr/>
+        </p:nvSpPr>
+        <p:spPr>
+          <a:xfrm>
+            <a:off x="228600" y="201168"/>
+            <a:ext cx="45720" cy="384048"/>
+          </a:xfrm>
+          <a:prstGeom prst="rect">
+            <a:avLst/>
+          </a:prstGeom>
+          <a:solidFill>
+            <a:srgbClr val="009696"/>
+          </a:solidFill>
+          <a:ln>
+            <a:noFill/>
+          </a:ln>
+        </p:spPr>
+        <p:style>
+          <a:lnRef idx="1">
+            <a:schemeClr val="accent1"/>
+          </a:lnRef>
+          <a:fillRef idx="3">
+            <a:schemeClr val="accent1"/>
+          </a:fillRef>
+          <a:effectRef idx="2">
+            <a:schemeClr val="accent1"/>
+          </a:effectRef>
+          <a:fontRef idx="minor">
+            <a:schemeClr val="lt1"/>
+          </a:fontRef>
+        </p:style>
+        <p:txBody>
+          <a:bodyPr rtlCol="0" anchor="ctr"/>
+          <a:lstStyle/>
+          <a:p>
+            <a:pPr algn="ctr"/>
+            <a:endParaRPr/>
+          </a:p>
+        </p:txBody>
+      </p:sp>
+      <p:sp>
+        <p:nvSpPr>
+          <p:cNvPr id="3" name="TextBox 2"/>
+          <p:cNvSpPr txBox="1"/>
+          <p:nvPr/>
+        </p:nvSpPr>
+        <p:spPr>
+          <a:xfrm>
+            <a:off x="320040" y="173736"/>
+            <a:ext cx="6035040" cy="365760"/>
+          </a:xfrm>
+          <a:prstGeom prst="rect">
+            <a:avLst/>
+          </a:prstGeom>
+          <a:noFill/>
+        </p:spPr>
+        <p:txBody>
+          <a:bodyPr wrap="square">
+            <a:normAutofit/>
+          </a:bodyPr>
+          <a:lstStyle/>
+          <a:p>
+            <a:pPr algn="l"/>
+            <a:r>
+              <a:rPr sz="1800" b="1">
+                <a:solidFill>
+                  <a:srgbClr val="16222E"/>
+                </a:solidFill>
+                <a:latin typeface="Aptos"/>
+              </a:rPr>
+              <a:t>Conformité au cahier des charges</a:t>
+            </a:r>
+          </a:p>
+        </p:txBody>
+      </p:sp>
+      <p:sp>
+        <p:nvSpPr>
+          <p:cNvPr id="4" name="TextBox 3"/>
+          <p:cNvSpPr txBox="1"/>
+          <p:nvPr/>
+        </p:nvSpPr>
+        <p:spPr>
+          <a:xfrm>
+            <a:off x="7315200" y="201168"/>
+            <a:ext cx="1554480" cy="219456"/>
+          </a:xfrm>
+          <a:prstGeom prst="rect">
+            <a:avLst/>
+          </a:prstGeom>
+          <a:noFill/>
+        </p:spPr>
+        <p:txBody>
+          <a:bodyPr wrap="square">
+            <a:normAutofit/>
+          </a:bodyPr>
+          <a:lstStyle/>
+          <a:p>
+            <a:pPr algn="r"/>
+            <a:r>
+              <a:rPr sz="850" b="0">
+                <a:solidFill>
+                  <a:srgbClr val="556473"/>
+                </a:solidFill>
+                <a:latin typeface="Aptos"/>
+              </a:rPr>
+              <a:t>EHPAD Monitor · V2</a:t>
+            </a:r>
+          </a:p>
+        </p:txBody>
+      </p:sp>
+      <p:sp>
+        <p:nvSpPr>
+          <p:cNvPr id="5" name="TextBox 4"/>
+          <p:cNvSpPr txBox="1"/>
+          <p:nvPr/>
+        </p:nvSpPr>
+        <p:spPr>
+          <a:xfrm>
+            <a:off x="6492240" y="109728"/>
+            <a:ext cx="914400" cy="182880"/>
+          </a:xfrm>
+          <a:prstGeom prst="rect">
+            <a:avLst/>
+          </a:prstGeom>
+          <a:noFill/>
+        </p:spPr>
+        <p:txBody>
+          <a:bodyPr wrap="square">
+            <a:normAutofit/>
+          </a:bodyPr>
+          <a:lstStyle/>
+          <a:p>
+            <a:pPr algn="r"/>
+            <a:r>
+              <a:rPr sz="800" b="0">
+                <a:solidFill>
+                  <a:srgbClr val="B4DAE1"/>
+                </a:solidFill>
+                <a:latin typeface="Aptos"/>
+              </a:rPr>
+              <a:t>─╱╲─╱╲────</a:t>
+            </a:r>
+          </a:p>
+        </p:txBody>
+      </p:sp>
+      <p:sp>
+        <p:nvSpPr>
+          <p:cNvPr id="6" name="Rectangle 5"/>
+          <p:cNvSpPr/>
+          <p:nvPr/>
+        </p:nvSpPr>
+        <p:spPr>
+          <a:xfrm>
+            <a:off x="228600" y="640080"/>
+            <a:ext cx="8686800" cy="10972"/>
+          </a:xfrm>
+          <a:prstGeom prst="rect">
+            <a:avLst/>
+          </a:prstGeom>
+          <a:solidFill>
+            <a:srgbClr val="D2E2E8"/>
+          </a:solidFill>
+          <a:ln>
+            <a:noFill/>
+          </a:ln>
+        </p:spPr>
+        <p:style>
+          <a:lnRef idx="1">
+            <a:schemeClr val="accent1"/>
+          </a:lnRef>
+          <a:fillRef idx="3">
+            <a:schemeClr val="accent1"/>
+          </a:fillRef>
+          <a:effectRef idx="2">
+            <a:schemeClr val="accent1"/>
+          </a:effectRef>
+          <a:fontRef idx="minor">
+            <a:schemeClr val="lt1"/>
+          </a:fontRef>
+        </p:style>
+        <p:txBody>
+          <a:bodyPr rtlCol="0" anchor="ctr"/>
+          <a:lstStyle/>
+          <a:p>
+            <a:pPr algn="ctr"/>
+            <a:endParaRPr/>
+          </a:p>
+        </p:txBody>
+      </p:sp>
+      <p:sp>
+        <p:nvSpPr>
+          <p:cNvPr id="7" name="TextBox 6"/>
+          <p:cNvSpPr txBox="1"/>
+          <p:nvPr/>
+        </p:nvSpPr>
+        <p:spPr>
+          <a:xfrm>
+            <a:off x="320040" y="749808"/>
+            <a:ext cx="8412480" cy="256032"/>
+          </a:xfrm>
+          <a:prstGeom prst="rect">
+            <a:avLst/>
+          </a:prstGeom>
+          <a:noFill/>
+        </p:spPr>
+        <p:txBody>
+          <a:bodyPr wrap="square">
+            <a:normAutofit/>
+          </a:bodyPr>
+          <a:lstStyle/>
+          <a:p>
+            <a:pPr algn="l"/>
+            <a:r>
+              <a:rPr sz="1250" b="0">
+                <a:solidFill>
+                  <a:srgbClr val="556473"/>
+                </a:solidFill>
+                <a:latin typeface="Aptos"/>
+              </a:rPr>
+              <a:t>Ce slide transforme la présentation en grille de lecture jury : chaque exigence est reliée à un élément démontrable.</a:t>
+            </a:r>
+          </a:p>
+        </p:txBody>
+      </p:sp>
+      <p:sp>
+        <p:nvSpPr>
+          <p:cNvPr id="8" name="Rounded Rectangle 7"/>
+          <p:cNvSpPr/>
+          <p:nvPr/>
+        </p:nvSpPr>
+        <p:spPr>
+          <a:xfrm>
+            <a:off x="320040" y="1097280"/>
+            <a:ext cx="4160520" cy="3520440"/>
+          </a:xfrm>
+          <a:prstGeom prst="roundRect">
+            <a:avLst/>
+          </a:prstGeom>
+          <a:solidFill>
+            <a:srgbClr val="FFFFFF"/>
+          </a:solidFill>
+          <a:ln w="12700">
+            <a:solidFill>
+              <a:srgbClr val="DCE6EB"/>
+            </a:solidFill>
+          </a:ln>
+        </p:spPr>
+        <p:style>
+          <a:lnRef idx="1">
+            <a:schemeClr val="accent1"/>
+          </a:lnRef>
+          <a:fillRef idx="3">
+            <a:schemeClr val="accent1"/>
+          </a:fillRef>
+          <a:effectRef idx="2">
+            <a:schemeClr val="accent1"/>
+          </a:effectRef>
+          <a:fontRef idx="minor">
+            <a:schemeClr val="lt1"/>
+          </a:fontRef>
+        </p:style>
+        <p:txBody>
+          <a:bodyPr rtlCol="0" anchor="ctr"/>
+          <a:lstStyle/>
+          <a:p>
+            <a:pPr algn="ctr"/>
+            <a:endParaRPr/>
+          </a:p>
+        </p:txBody>
+      </p:sp>
+      <p:sp>
+        <p:nvSpPr>
+          <p:cNvPr id="9" name="Rectangle 8"/>
+          <p:cNvSpPr/>
+          <p:nvPr/>
+        </p:nvSpPr>
+        <p:spPr>
+          <a:xfrm>
+            <a:off x="320040" y="1097280"/>
+            <a:ext cx="4160520" cy="329184"/>
+          </a:xfrm>
+          <a:prstGeom prst="rect">
+            <a:avLst/>
+          </a:prstGeom>
+          <a:solidFill>
+            <a:srgbClr val="009696"/>
+          </a:solidFill>
+          <a:ln>
+            <a:noFill/>
+          </a:ln>
+        </p:spPr>
+        <p:style>
+          <a:lnRef idx="1">
+            <a:schemeClr val="accent1"/>
+          </a:lnRef>
+          <a:fillRef idx="3">
+            <a:schemeClr val="accent1"/>
+          </a:fillRef>
+          <a:effectRef idx="2">
+            <a:schemeClr val="accent1"/>
+          </a:effectRef>
+          <a:fontRef idx="minor">
+            <a:schemeClr val="lt1"/>
+          </a:fontRef>
+        </p:style>
+        <p:txBody>
+          <a:bodyPr rtlCol="0" anchor="ctr"/>
+          <a:lstStyle/>
+          <a:p>
+            <a:pPr algn="ctr"/>
+            <a:endParaRPr/>
+          </a:p>
+        </p:txBody>
+      </p:sp>
+      <p:sp>
+        <p:nvSpPr>
+          <p:cNvPr id="10" name="TextBox 9"/>
+          <p:cNvSpPr txBox="1"/>
+          <p:nvPr/>
+        </p:nvSpPr>
+        <p:spPr>
+          <a:xfrm>
+            <a:off x="484632" y="1161288"/>
+            <a:ext cx="3794760" cy="201168"/>
+          </a:xfrm>
+          <a:prstGeom prst="rect">
+            <a:avLst/>
+          </a:prstGeom>
+          <a:noFill/>
+        </p:spPr>
+        <p:txBody>
+          <a:bodyPr wrap="square">
+            <a:normAutofit/>
+          </a:bodyPr>
+          <a:lstStyle/>
+          <a:p>
+            <a:pPr algn="l"/>
+            <a:r>
+              <a:rPr sz="1200" b="1">
+                <a:solidFill>
+                  <a:srgbClr val="FFFFFF"/>
+                </a:solidFill>
+                <a:latin typeface="Aptos"/>
+              </a:rPr>
+              <a:t>MUST HAVE — état du rendu</a:t>
+            </a:r>
+          </a:p>
+        </p:txBody>
+      </p:sp>
+      <p:sp>
+        <p:nvSpPr>
+          <p:cNvPr id="11" name="TextBox 10"/>
+          <p:cNvSpPr txBox="1"/>
+          <p:nvPr/>
+        </p:nvSpPr>
+        <p:spPr>
+          <a:xfrm>
+            <a:off x="502920" y="1554480"/>
+            <a:ext cx="320040" cy="201168"/>
+          </a:xfrm>
+          <a:prstGeom prst="rect">
+            <a:avLst/>
+          </a:prstGeom>
+          <a:noFill/>
+        </p:spPr>
+        <p:txBody>
+          <a:bodyPr wrap="square">
+            <a:normAutofit/>
+          </a:bodyPr>
+          <a:lstStyle/>
+          <a:p>
+            <a:pPr algn="l"/>
+            <a:r>
+              <a:rPr sz="950" b="1">
+                <a:solidFill>
+                  <a:srgbClr val="009696"/>
+                </a:solidFill>
+                <a:latin typeface="Aptos"/>
+              </a:rPr>
+              <a:t>M1</a:t>
+            </a:r>
+          </a:p>
+        </p:txBody>
+      </p:sp>
+      <p:sp>
+        <p:nvSpPr>
+          <p:cNvPr id="12" name="TextBox 11"/>
+          <p:cNvSpPr txBox="1"/>
+          <p:nvPr/>
+        </p:nvSpPr>
+        <p:spPr>
+          <a:xfrm>
+            <a:off x="868680" y="1554480"/>
+            <a:ext cx="2788920" cy="201168"/>
+          </a:xfrm>
+          <a:prstGeom prst="rect">
+            <a:avLst/>
+          </a:prstGeom>
+          <a:noFill/>
+        </p:spPr>
+        <p:txBody>
+          <a:bodyPr wrap="square">
+            <a:normAutofit/>
+          </a:bodyPr>
+          <a:lstStyle/>
+          <a:p>
+            <a:pPr algn="l"/>
+            <a:r>
+              <a:rPr sz="919" b="0">
+                <a:solidFill>
+                  <a:srgbClr val="16222E"/>
+                </a:solidFill>
+                <a:latin typeface="Aptos"/>
+              </a:rPr>
+              <a:t>25 résidents + profils pathologies/mobilité</a:t>
+            </a:r>
+          </a:p>
+        </p:txBody>
+      </p:sp>
+      <p:sp>
+        <p:nvSpPr>
+          <p:cNvPr id="13" name="TextBox 12"/>
+          <p:cNvSpPr txBox="1"/>
+          <p:nvPr/>
+        </p:nvSpPr>
+        <p:spPr>
+          <a:xfrm>
+            <a:off x="3703320" y="1554480"/>
+            <a:ext cx="566928" cy="201168"/>
+          </a:xfrm>
+          <a:prstGeom prst="rect">
+            <a:avLst/>
+          </a:prstGeom>
+          <a:noFill/>
+        </p:spPr>
+        <p:txBody>
+          <a:bodyPr wrap="square">
+            <a:normAutofit/>
+          </a:bodyPr>
+          <a:lstStyle/>
+          <a:p>
+            <a:pPr algn="r"/>
+            <a:r>
+              <a:rPr sz="880" b="1">
+                <a:solidFill>
+                  <a:srgbClr val="0FA569"/>
+                </a:solidFill>
+                <a:latin typeface="Aptos"/>
+              </a:rPr>
+              <a:t>OK</a:t>
+            </a:r>
+          </a:p>
+        </p:txBody>
+      </p:sp>
+      <p:sp>
+        <p:nvSpPr>
+          <p:cNvPr id="14" name="TextBox 13"/>
+          <p:cNvSpPr txBox="1"/>
+          <p:nvPr/>
+        </p:nvSpPr>
+        <p:spPr>
+          <a:xfrm>
+            <a:off x="502920" y="1947672"/>
+            <a:ext cx="320040" cy="201168"/>
+          </a:xfrm>
+          <a:prstGeom prst="rect">
+            <a:avLst/>
+          </a:prstGeom>
+          <a:noFill/>
+        </p:spPr>
+        <p:txBody>
+          <a:bodyPr wrap="square">
+            <a:normAutofit/>
+          </a:bodyPr>
+          <a:lstStyle/>
+          <a:p>
+            <a:pPr algn="l"/>
+            <a:r>
+              <a:rPr sz="950" b="1">
+                <a:solidFill>
+                  <a:srgbClr val="009696"/>
+                </a:solidFill>
+                <a:latin typeface="Aptos"/>
+              </a:rPr>
+              <a:t>M2</a:t>
+            </a:r>
+          </a:p>
+        </p:txBody>
+      </p:sp>
+      <p:sp>
+        <p:nvSpPr>
+          <p:cNvPr id="15" name="TextBox 14"/>
+          <p:cNvSpPr txBox="1"/>
+          <p:nvPr/>
+        </p:nvSpPr>
+        <p:spPr>
+          <a:xfrm>
+            <a:off x="868680" y="1947672"/>
+            <a:ext cx="2788920" cy="201168"/>
+          </a:xfrm>
+          <a:prstGeom prst="rect">
+            <a:avLst/>
+          </a:prstGeom>
+          <a:noFill/>
+        </p:spPr>
+        <p:txBody>
+          <a:bodyPr wrap="square">
+            <a:normAutofit/>
+          </a:bodyPr>
+          <a:lstStyle/>
+          <a:p>
+            <a:pPr algn="l"/>
+            <a:r>
+              <a:rPr sz="919" b="0">
+                <a:solidFill>
+                  <a:srgbClr val="16222E"/>
+                </a:solidFill>
+                <a:latin typeface="Aptos"/>
+              </a:rPr>
+              <a:t>Capteurs vitaux + ambiants + portes/zones</a:t>
+            </a:r>
+          </a:p>
+        </p:txBody>
+      </p:sp>
+      <p:sp>
+        <p:nvSpPr>
+          <p:cNvPr id="16" name="TextBox 15"/>
+          <p:cNvSpPr txBox="1"/>
+          <p:nvPr/>
+        </p:nvSpPr>
+        <p:spPr>
+          <a:xfrm>
+            <a:off x="3703320" y="1947672"/>
+            <a:ext cx="566928" cy="201168"/>
+          </a:xfrm>
+          <a:prstGeom prst="rect">
+            <a:avLst/>
+          </a:prstGeom>
+          <a:noFill/>
+        </p:spPr>
+        <p:txBody>
+          <a:bodyPr wrap="square">
+            <a:normAutofit/>
+          </a:bodyPr>
+          <a:lstStyle/>
+          <a:p>
+            <a:pPr algn="r"/>
+            <a:r>
+              <a:rPr sz="880" b="1">
+                <a:solidFill>
+                  <a:srgbClr val="0FA569"/>
+                </a:solidFill>
+                <a:latin typeface="Aptos"/>
+              </a:rPr>
+              <a:t>OK</a:t>
+            </a:r>
+          </a:p>
+        </p:txBody>
+      </p:sp>
+      <p:sp>
+        <p:nvSpPr>
+          <p:cNvPr id="17" name="TextBox 16"/>
+          <p:cNvSpPr txBox="1"/>
+          <p:nvPr/>
+        </p:nvSpPr>
+        <p:spPr>
+          <a:xfrm>
+            <a:off x="502920" y="2340864"/>
+            <a:ext cx="320040" cy="201168"/>
+          </a:xfrm>
+          <a:prstGeom prst="rect">
+            <a:avLst/>
+          </a:prstGeom>
+          <a:noFill/>
+        </p:spPr>
+        <p:txBody>
+          <a:bodyPr wrap="square">
+            <a:normAutofit/>
+          </a:bodyPr>
+          <a:lstStyle/>
+          <a:p>
+            <a:pPr algn="l"/>
+            <a:r>
+              <a:rPr sz="950" b="1">
+                <a:solidFill>
+                  <a:srgbClr val="009696"/>
+                </a:solidFill>
+                <a:latin typeface="Aptos"/>
+              </a:rPr>
+              <a:t>M3</a:t>
+            </a:r>
+          </a:p>
+        </p:txBody>
+      </p:sp>
+      <p:sp>
+        <p:nvSpPr>
+          <p:cNvPr id="18" name="TextBox 17"/>
+          <p:cNvSpPr txBox="1"/>
+          <p:nvPr/>
+        </p:nvSpPr>
+        <p:spPr>
+          <a:xfrm>
+            <a:off x="868680" y="2340864"/>
+            <a:ext cx="2788920" cy="201168"/>
+          </a:xfrm>
+          <a:prstGeom prst="rect">
+            <a:avLst/>
+          </a:prstGeom>
+          <a:noFill/>
+        </p:spPr>
+        <p:txBody>
+          <a:bodyPr wrap="square">
+            <a:normAutofit/>
+          </a:bodyPr>
+          <a:lstStyle/>
+          <a:p>
+            <a:pPr algn="l"/>
+            <a:r>
+              <a:rPr sz="919" b="0">
+                <a:solidFill>
+                  <a:srgbClr val="16222E"/>
+                </a:solidFill>
+                <a:latin typeface="Aptos"/>
+              </a:rPr>
+              <a:t>MQTT topics résidents/zones + QoS</a:t>
+            </a:r>
+          </a:p>
+        </p:txBody>
+      </p:sp>
+      <p:sp>
+        <p:nvSpPr>
+          <p:cNvPr id="19" name="TextBox 18"/>
+          <p:cNvSpPr txBox="1"/>
+          <p:nvPr/>
+        </p:nvSpPr>
+        <p:spPr>
+          <a:xfrm>
+            <a:off x="3703320" y="2340864"/>
+            <a:ext cx="566928" cy="201168"/>
+          </a:xfrm>
+          <a:prstGeom prst="rect">
+            <a:avLst/>
+          </a:prstGeom>
+          <a:noFill/>
+        </p:spPr>
+        <p:txBody>
+          <a:bodyPr wrap="square">
+            <a:normAutofit/>
+          </a:bodyPr>
+          <a:lstStyle/>
+          <a:p>
+            <a:pPr algn="r"/>
+            <a:r>
+              <a:rPr sz="880" b="1">
+                <a:solidFill>
+                  <a:srgbClr val="0FA569"/>
+                </a:solidFill>
+                <a:latin typeface="Aptos"/>
+              </a:rPr>
+              <a:t>OK</a:t>
+            </a:r>
+          </a:p>
+        </p:txBody>
+      </p:sp>
+      <p:sp>
+        <p:nvSpPr>
+          <p:cNvPr id="20" name="TextBox 19"/>
+          <p:cNvSpPr txBox="1"/>
+          <p:nvPr/>
+        </p:nvSpPr>
+        <p:spPr>
+          <a:xfrm>
+            <a:off x="502920" y="2734056"/>
+            <a:ext cx="320040" cy="201168"/>
+          </a:xfrm>
+          <a:prstGeom prst="rect">
+            <a:avLst/>
+          </a:prstGeom>
+          <a:noFill/>
+        </p:spPr>
+        <p:txBody>
+          <a:bodyPr wrap="square">
+            <a:normAutofit/>
+          </a:bodyPr>
+          <a:lstStyle/>
+          <a:p>
+            <a:pPr algn="l"/>
+            <a:r>
+              <a:rPr sz="950" b="1">
+                <a:solidFill>
+                  <a:srgbClr val="009696"/>
+                </a:solidFill>
+                <a:latin typeface="Aptos"/>
+              </a:rPr>
+              <a:t>M4</a:t>
+            </a:r>
+          </a:p>
+        </p:txBody>
+      </p:sp>
+      <p:sp>
+        <p:nvSpPr>
+          <p:cNvPr id="21" name="TextBox 20"/>
+          <p:cNvSpPr txBox="1"/>
+          <p:nvPr/>
+        </p:nvSpPr>
+        <p:spPr>
+          <a:xfrm>
+            <a:off x="868680" y="2734056"/>
+            <a:ext cx="2788920" cy="201168"/>
+          </a:xfrm>
+          <a:prstGeom prst="rect">
+            <a:avLst/>
+          </a:prstGeom>
+          <a:noFill/>
+        </p:spPr>
+        <p:txBody>
+          <a:bodyPr wrap="square">
+            <a:normAutofit/>
+          </a:bodyPr>
+          <a:lstStyle/>
+          <a:p>
+            <a:pPr algn="l"/>
+            <a:r>
+              <a:rPr sz="919" b="0">
+                <a:solidFill>
+                  <a:srgbClr val="16222E"/>
+                </a:solidFill>
+                <a:latin typeface="Aptos"/>
+              </a:rPr>
+              <a:t>Dashboard global + drill-down résident</a:t>
+            </a:r>
+          </a:p>
+        </p:txBody>
+      </p:sp>
+      <p:sp>
+        <p:nvSpPr>
+          <p:cNvPr id="22" name="TextBox 21"/>
+          <p:cNvSpPr txBox="1"/>
+          <p:nvPr/>
+        </p:nvSpPr>
+        <p:spPr>
+          <a:xfrm>
+            <a:off x="3703320" y="2734056"/>
+            <a:ext cx="566928" cy="201168"/>
+          </a:xfrm>
+          <a:prstGeom prst="rect">
+            <a:avLst/>
+          </a:prstGeom>
+          <a:noFill/>
+        </p:spPr>
+        <p:txBody>
+          <a:bodyPr wrap="square">
+            <a:normAutofit/>
+          </a:bodyPr>
+          <a:lstStyle/>
+          <a:p>
+            <a:pPr algn="r"/>
+            <a:r>
+              <a:rPr sz="880" b="1">
+                <a:solidFill>
+                  <a:srgbClr val="0FA569"/>
+                </a:solidFill>
+                <a:latin typeface="Aptos"/>
+              </a:rPr>
+              <a:t>OK</a:t>
+            </a:r>
+          </a:p>
+        </p:txBody>
+      </p:sp>
+      <p:sp>
+        <p:nvSpPr>
+          <p:cNvPr id="23" name="TextBox 22"/>
+          <p:cNvSpPr txBox="1"/>
+          <p:nvPr/>
+        </p:nvSpPr>
+        <p:spPr>
+          <a:xfrm>
+            <a:off x="502920" y="3127248"/>
+            <a:ext cx="320040" cy="201168"/>
+          </a:xfrm>
+          <a:prstGeom prst="rect">
+            <a:avLst/>
+          </a:prstGeom>
+          <a:noFill/>
+        </p:spPr>
+        <p:txBody>
+          <a:bodyPr wrap="square">
+            <a:normAutofit/>
+          </a:bodyPr>
+          <a:lstStyle/>
+          <a:p>
+            <a:pPr algn="l"/>
+            <a:r>
+              <a:rPr sz="950" b="1">
+                <a:solidFill>
+                  <a:srgbClr val="009696"/>
+                </a:solidFill>
+                <a:latin typeface="Aptos"/>
+              </a:rPr>
+              <a:t>M5</a:t>
+            </a:r>
+          </a:p>
+        </p:txBody>
+      </p:sp>
+      <p:sp>
+        <p:nvSpPr>
+          <p:cNvPr id="24" name="TextBox 23"/>
+          <p:cNvSpPr txBox="1"/>
+          <p:nvPr/>
+        </p:nvSpPr>
+        <p:spPr>
+          <a:xfrm>
+            <a:off x="868680" y="3127248"/>
+            <a:ext cx="2788920" cy="201168"/>
+          </a:xfrm>
+          <a:prstGeom prst="rect">
+            <a:avLst/>
+          </a:prstGeom>
+          <a:noFill/>
+        </p:spPr>
+        <p:txBody>
+          <a:bodyPr wrap="square">
+            <a:normAutofit/>
+          </a:bodyPr>
+          <a:lstStyle/>
+          <a:p>
+            <a:pPr algn="l"/>
+            <a:r>
+              <a:rPr sz="919" b="0">
+                <a:solidFill>
+                  <a:srgbClr val="16222E"/>
+                </a:solidFill>
+                <a:latin typeface="Aptos"/>
+              </a:rPr>
+              <a:t>Alertes 5 niveaux + acquittement/escalade</a:t>
+            </a:r>
+          </a:p>
+        </p:txBody>
+      </p:sp>
+      <p:sp>
+        <p:nvSpPr>
+          <p:cNvPr id="25" name="TextBox 24"/>
+          <p:cNvSpPr txBox="1"/>
+          <p:nvPr/>
+        </p:nvSpPr>
+        <p:spPr>
+          <a:xfrm>
+            <a:off x="3703320" y="3127248"/>
+            <a:ext cx="566928" cy="201168"/>
+          </a:xfrm>
+          <a:prstGeom prst="rect">
+            <a:avLst/>
+          </a:prstGeom>
+          <a:noFill/>
+        </p:spPr>
+        <p:txBody>
+          <a:bodyPr wrap="square">
+            <a:normAutofit/>
+          </a:bodyPr>
+          <a:lstStyle/>
+          <a:p>
+            <a:pPr algn="r"/>
+            <a:r>
+              <a:rPr sz="880" b="1">
+                <a:solidFill>
+                  <a:srgbClr val="0FA569"/>
+                </a:solidFill>
+                <a:latin typeface="Aptos"/>
+              </a:rPr>
+              <a:t>OK démo</a:t>
+            </a:r>
+          </a:p>
+        </p:txBody>
+      </p:sp>
+      <p:sp>
+        <p:nvSpPr>
+          <p:cNvPr id="26" name="TextBox 25"/>
+          <p:cNvSpPr txBox="1"/>
+          <p:nvPr/>
+        </p:nvSpPr>
+        <p:spPr>
+          <a:xfrm>
+            <a:off x="502920" y="3520440"/>
+            <a:ext cx="320040" cy="201168"/>
+          </a:xfrm>
+          <a:prstGeom prst="rect">
+            <a:avLst/>
+          </a:prstGeom>
+          <a:noFill/>
+        </p:spPr>
+        <p:txBody>
+          <a:bodyPr wrap="square">
+            <a:normAutofit/>
+          </a:bodyPr>
+          <a:lstStyle/>
+          <a:p>
+            <a:pPr algn="l"/>
+            <a:r>
+              <a:rPr sz="950" b="1">
+                <a:solidFill>
+                  <a:srgbClr val="009696"/>
+                </a:solidFill>
+                <a:latin typeface="Aptos"/>
+              </a:rPr>
+              <a:t>M6</a:t>
+            </a:r>
+          </a:p>
+        </p:txBody>
+      </p:sp>
+      <p:sp>
+        <p:nvSpPr>
+          <p:cNvPr id="27" name="TextBox 26"/>
+          <p:cNvSpPr txBox="1"/>
+          <p:nvPr/>
+        </p:nvSpPr>
+        <p:spPr>
+          <a:xfrm>
+            <a:off x="868680" y="3520440"/>
+            <a:ext cx="2788920" cy="201168"/>
+          </a:xfrm>
+          <a:prstGeom prst="rect">
+            <a:avLst/>
+          </a:prstGeom>
+          <a:noFill/>
+        </p:spPr>
+        <p:txBody>
+          <a:bodyPr wrap="square">
+            <a:normAutofit/>
+          </a:bodyPr>
+          <a:lstStyle/>
+          <a:p>
+            <a:pPr algn="l"/>
+            <a:r>
+              <a:rPr sz="919" b="0">
+                <a:solidFill>
+                  <a:srgbClr val="16222E"/>
+                </a:solidFill>
+                <a:latin typeface="Aptos"/>
+              </a:rPr>
+              <a:t>Docker Compose fonctionnel</a:t>
+            </a:r>
+          </a:p>
+        </p:txBody>
+      </p:sp>
+      <p:sp>
+        <p:nvSpPr>
+          <p:cNvPr id="28" name="TextBox 27"/>
+          <p:cNvSpPr txBox="1"/>
+          <p:nvPr/>
+        </p:nvSpPr>
+        <p:spPr>
+          <a:xfrm>
+            <a:off x="3703320" y="3520440"/>
+            <a:ext cx="566928" cy="201168"/>
+          </a:xfrm>
+          <a:prstGeom prst="rect">
+            <a:avLst/>
+          </a:prstGeom>
+          <a:noFill/>
+        </p:spPr>
+        <p:txBody>
+          <a:bodyPr wrap="square">
+            <a:normAutofit/>
+          </a:bodyPr>
+          <a:lstStyle/>
+          <a:p>
+            <a:pPr algn="r"/>
+            <a:r>
+              <a:rPr sz="880" b="1">
+                <a:solidFill>
+                  <a:srgbClr val="0FA569"/>
+                </a:solidFill>
+                <a:latin typeface="Aptos"/>
+              </a:rPr>
+              <a:t>OK</a:t>
+            </a:r>
+          </a:p>
+        </p:txBody>
+      </p:sp>
+      <p:sp>
+        <p:nvSpPr>
+          <p:cNvPr id="29" name="TextBox 28"/>
+          <p:cNvSpPr txBox="1"/>
+          <p:nvPr/>
+        </p:nvSpPr>
+        <p:spPr>
+          <a:xfrm>
+            <a:off x="502920" y="3913632"/>
+            <a:ext cx="320040" cy="201168"/>
+          </a:xfrm>
+          <a:prstGeom prst="rect">
+            <a:avLst/>
+          </a:prstGeom>
+          <a:noFill/>
+        </p:spPr>
+        <p:txBody>
+          <a:bodyPr wrap="square">
+            <a:normAutofit/>
+          </a:bodyPr>
+          <a:lstStyle/>
+          <a:p>
+            <a:pPr algn="l"/>
+            <a:r>
+              <a:rPr sz="950" b="1">
+                <a:solidFill>
+                  <a:srgbClr val="009696"/>
+                </a:solidFill>
+                <a:latin typeface="Aptos"/>
+              </a:rPr>
+              <a:t>M7</a:t>
+            </a:r>
+          </a:p>
+        </p:txBody>
+      </p:sp>
+      <p:sp>
+        <p:nvSpPr>
+          <p:cNvPr id="30" name="TextBox 29"/>
+          <p:cNvSpPr txBox="1"/>
+          <p:nvPr/>
+        </p:nvSpPr>
+        <p:spPr>
+          <a:xfrm>
+            <a:off x="868680" y="3913632"/>
+            <a:ext cx="2788920" cy="201168"/>
+          </a:xfrm>
+          <a:prstGeom prst="rect">
+            <a:avLst/>
+          </a:prstGeom>
+          <a:noFill/>
+        </p:spPr>
+        <p:txBody>
+          <a:bodyPr wrap="square">
+            <a:normAutofit/>
+          </a:bodyPr>
+          <a:lstStyle/>
+          <a:p>
+            <a:pPr algn="l"/>
+            <a:r>
+              <a:rPr sz="919" b="0">
+                <a:solidFill>
+                  <a:srgbClr val="16222E"/>
+                </a:solidFill>
+                <a:latin typeface="Aptos"/>
+              </a:rPr>
+              <a:t>README + docs architecture + sécurité</a:t>
+            </a:r>
+          </a:p>
+        </p:txBody>
+      </p:sp>
+      <p:sp>
+        <p:nvSpPr>
+          <p:cNvPr id="31" name="TextBox 30"/>
+          <p:cNvSpPr txBox="1"/>
+          <p:nvPr/>
+        </p:nvSpPr>
+        <p:spPr>
+          <a:xfrm>
+            <a:off x="3703320" y="3913632"/>
+            <a:ext cx="566928" cy="201168"/>
+          </a:xfrm>
+          <a:prstGeom prst="rect">
+            <a:avLst/>
+          </a:prstGeom>
+          <a:noFill/>
+        </p:spPr>
+        <p:txBody>
+          <a:bodyPr wrap="square">
+            <a:normAutofit/>
+          </a:bodyPr>
+          <a:lstStyle/>
+          <a:p>
+            <a:pPr algn="r"/>
+            <a:r>
+              <a:rPr sz="880" b="1">
+                <a:solidFill>
+                  <a:srgbClr val="0FA569"/>
+                </a:solidFill>
+                <a:latin typeface="Aptos"/>
+              </a:rPr>
+              <a:t>OK</a:t>
+            </a:r>
+          </a:p>
+        </p:txBody>
+      </p:sp>
+      <p:sp>
+        <p:nvSpPr>
+          <p:cNvPr id="32" name="Rounded Rectangle 31"/>
+          <p:cNvSpPr/>
+          <p:nvPr/>
+        </p:nvSpPr>
+        <p:spPr>
+          <a:xfrm>
+            <a:off x="4663440" y="1097280"/>
+            <a:ext cx="4160520" cy="3520440"/>
+          </a:xfrm>
+          <a:prstGeom prst="roundRect">
+            <a:avLst/>
+          </a:prstGeom>
+          <a:solidFill>
+            <a:srgbClr val="FFFFFF"/>
+          </a:solidFill>
+          <a:ln w="12700">
+            <a:solidFill>
+              <a:srgbClr val="DCE6EB"/>
+            </a:solidFill>
+          </a:ln>
+        </p:spPr>
+        <p:style>
+          <a:lnRef idx="1">
+            <a:schemeClr val="accent1"/>
+          </a:lnRef>
+          <a:fillRef idx="3">
+            <a:schemeClr val="accent1"/>
+          </a:fillRef>
+          <a:effectRef idx="2">
+            <a:schemeClr val="accent1"/>
+          </a:effectRef>
+          <a:fontRef idx="minor">
+            <a:schemeClr val="lt1"/>
+          </a:fontRef>
+        </p:style>
+        <p:txBody>
+          <a:bodyPr rtlCol="0" anchor="ctr"/>
+          <a:lstStyle/>
+          <a:p>
+            <a:pPr algn="ctr"/>
+            <a:endParaRPr/>
+          </a:p>
+        </p:txBody>
+      </p:sp>
+      <p:sp>
+        <p:nvSpPr>
+          <p:cNvPr id="33" name="Rectangle 32"/>
+          <p:cNvSpPr/>
+          <p:nvPr/>
+        </p:nvSpPr>
+        <p:spPr>
+          <a:xfrm>
+            <a:off x="4663440" y="1097280"/>
+            <a:ext cx="4160520" cy="329184"/>
+          </a:xfrm>
+          <a:prstGeom prst="rect">
+            <a:avLst/>
+          </a:prstGeom>
+          <a:solidFill>
+            <a:srgbClr val="E97D37"/>
+          </a:solidFill>
+          <a:ln>
+            <a:noFill/>
+          </a:ln>
+        </p:spPr>
+        <p:style>
+          <a:lnRef idx="1">
+            <a:schemeClr val="accent1"/>
+          </a:lnRef>
+          <a:fillRef idx="3">
+            <a:schemeClr val="accent1"/>
+          </a:fillRef>
+          <a:effectRef idx="2">
+            <a:schemeClr val="accent1"/>
+          </a:effectRef>
+          <a:fontRef idx="minor">
+            <a:schemeClr val="lt1"/>
+          </a:fontRef>
+        </p:style>
+        <p:txBody>
+          <a:bodyPr rtlCol="0" anchor="ctr"/>
+          <a:lstStyle/>
+          <a:p>
+            <a:pPr algn="ctr"/>
+            <a:endParaRPr/>
+          </a:p>
+        </p:txBody>
+      </p:sp>
+      <p:sp>
+        <p:nvSpPr>
+          <p:cNvPr id="34" name="TextBox 33"/>
+          <p:cNvSpPr txBox="1"/>
+          <p:nvPr/>
+        </p:nvSpPr>
+        <p:spPr>
+          <a:xfrm>
+            <a:off x="4828032" y="1161288"/>
+            <a:ext cx="3794760" cy="201168"/>
+          </a:xfrm>
+          <a:prstGeom prst="rect">
+            <a:avLst/>
+          </a:prstGeom>
+          <a:noFill/>
+        </p:spPr>
+        <p:txBody>
+          <a:bodyPr wrap="square">
+            <a:normAutofit/>
+          </a:bodyPr>
+          <a:lstStyle/>
+          <a:p>
+            <a:pPr algn="l"/>
+            <a:r>
+              <a:rPr sz="1200" b="1">
+                <a:solidFill>
+                  <a:srgbClr val="FFFFFF"/>
+                </a:solidFill>
+                <a:latin typeface="Aptos"/>
+              </a:rPr>
+              <a:t>SHOULD / COULD — bonus valorisables</a:t>
+            </a:r>
+          </a:p>
+        </p:txBody>
+      </p:sp>
+      <p:sp>
+        <p:nvSpPr>
+          <p:cNvPr id="35" name="TextBox 34"/>
+          <p:cNvSpPr txBox="1"/>
+          <p:nvPr/>
+        </p:nvSpPr>
+        <p:spPr>
+          <a:xfrm>
+            <a:off x="4864608" y="1554480"/>
+            <a:ext cx="530352" cy="201168"/>
+          </a:xfrm>
+          <a:prstGeom prst="rect">
+            <a:avLst/>
+          </a:prstGeom>
+          <a:noFill/>
+        </p:spPr>
+        <p:txBody>
+          <a:bodyPr wrap="square">
+            <a:normAutofit/>
+          </a:bodyPr>
+          <a:lstStyle/>
+          <a:p>
+            <a:pPr algn="l"/>
+            <a:r>
+              <a:rPr sz="950" b="1">
+                <a:solidFill>
+                  <a:srgbClr val="E97D37"/>
+                </a:solidFill>
+                <a:latin typeface="Aptos"/>
+              </a:rPr>
+              <a:t>S1</a:t>
+            </a:r>
+          </a:p>
+        </p:txBody>
+      </p:sp>
+      <p:sp>
+        <p:nvSpPr>
+          <p:cNvPr id="36" name="TextBox 35"/>
+          <p:cNvSpPr txBox="1"/>
+          <p:nvPr/>
+        </p:nvSpPr>
+        <p:spPr>
+          <a:xfrm>
+            <a:off x="5440680" y="1554480"/>
+            <a:ext cx="3063240" cy="201168"/>
+          </a:xfrm>
+          <a:prstGeom prst="rect">
+            <a:avLst/>
+          </a:prstGeom>
+          <a:noFill/>
+        </p:spPr>
+        <p:txBody>
+          <a:bodyPr wrap="square">
+            <a:normAutofit/>
+          </a:bodyPr>
+          <a:lstStyle/>
+          <a:p>
+            <a:pPr algn="l"/>
+            <a:r>
+              <a:rPr sz="919" b="0">
+                <a:solidFill>
+                  <a:srgbClr val="16222E"/>
+                </a:solidFill>
+                <a:latin typeface="Aptos"/>
+              </a:rPr>
+              <a:t>Prédiction ML 30–60 min + risk_30/risk_60</a:t>
+            </a:r>
+          </a:p>
+        </p:txBody>
+      </p:sp>
+      <p:sp>
+        <p:nvSpPr>
+          <p:cNvPr id="37" name="TextBox 36"/>
+          <p:cNvSpPr txBox="1"/>
+          <p:nvPr/>
+        </p:nvSpPr>
+        <p:spPr>
+          <a:xfrm>
+            <a:off x="8458200" y="1554480"/>
+            <a:ext cx="182880" cy="201168"/>
+          </a:xfrm>
+          <a:prstGeom prst="rect">
+            <a:avLst/>
+          </a:prstGeom>
+          <a:noFill/>
+        </p:spPr>
+        <p:txBody>
+          <a:bodyPr wrap="square">
+            <a:normAutofit/>
+          </a:bodyPr>
+          <a:lstStyle/>
+          <a:p>
+            <a:pPr algn="r"/>
+            <a:r>
+              <a:rPr sz="1000" b="1">
+                <a:solidFill>
+                  <a:srgbClr val="0FA569"/>
+                </a:solidFill>
+                <a:latin typeface="Aptos"/>
+              </a:rPr>
+              <a:t>✓</a:t>
+            </a:r>
+          </a:p>
+        </p:txBody>
+      </p:sp>
+      <p:sp>
+        <p:nvSpPr>
+          <p:cNvPr id="38" name="TextBox 37"/>
+          <p:cNvSpPr txBox="1"/>
+          <p:nvPr/>
+        </p:nvSpPr>
+        <p:spPr>
+          <a:xfrm>
+            <a:off x="4864608" y="1947672"/>
+            <a:ext cx="530352" cy="201168"/>
+          </a:xfrm>
+          <a:prstGeom prst="rect">
+            <a:avLst/>
+          </a:prstGeom>
+          <a:noFill/>
+        </p:spPr>
+        <p:txBody>
+          <a:bodyPr wrap="square">
+            <a:normAutofit/>
+          </a:bodyPr>
+          <a:lstStyle/>
+          <a:p>
+            <a:pPr algn="l"/>
+            <a:r>
+              <a:rPr sz="950" b="1">
+                <a:solidFill>
+                  <a:srgbClr val="E97D37"/>
+                </a:solidFill>
+                <a:latin typeface="Aptos"/>
+              </a:rPr>
+              <a:t>S2</a:t>
+            </a:r>
+          </a:p>
+        </p:txBody>
+      </p:sp>
+      <p:sp>
+        <p:nvSpPr>
+          <p:cNvPr id="39" name="TextBox 38"/>
+          <p:cNvSpPr txBox="1"/>
+          <p:nvPr/>
+        </p:nvSpPr>
+        <p:spPr>
+          <a:xfrm>
+            <a:off x="5440680" y="1947672"/>
+            <a:ext cx="3063240" cy="201168"/>
+          </a:xfrm>
+          <a:prstGeom prst="rect">
+            <a:avLst/>
+          </a:prstGeom>
+          <a:noFill/>
+        </p:spPr>
+        <p:txBody>
+          <a:bodyPr wrap="square">
+            <a:normAutofit/>
+          </a:bodyPr>
+          <a:lstStyle/>
+          <a:p>
+            <a:pPr algn="l"/>
+            <a:r>
+              <a:rPr sz="919" b="0">
+                <a:solidFill>
+                  <a:srgbClr val="16222E"/>
+                </a:solidFill>
+                <a:latin typeface="Aptos"/>
+              </a:rPr>
+              <a:t>Plan/position EHPAD via zones et localisation</a:t>
+            </a:r>
+          </a:p>
+        </p:txBody>
+      </p:sp>
+      <p:sp>
+        <p:nvSpPr>
+          <p:cNvPr id="40" name="TextBox 39"/>
+          <p:cNvSpPr txBox="1"/>
+          <p:nvPr/>
+        </p:nvSpPr>
+        <p:spPr>
+          <a:xfrm>
+            <a:off x="8458200" y="1947672"/>
+            <a:ext cx="182880" cy="201168"/>
+          </a:xfrm>
+          <a:prstGeom prst="rect">
+            <a:avLst/>
+          </a:prstGeom>
+          <a:noFill/>
+        </p:spPr>
+        <p:txBody>
+          <a:bodyPr wrap="square">
+            <a:normAutofit/>
+          </a:bodyPr>
+          <a:lstStyle/>
+          <a:p>
+            <a:pPr algn="r"/>
+            <a:r>
+              <a:rPr sz="1000" b="1">
+                <a:solidFill>
+                  <a:srgbClr val="0FA569"/>
+                </a:solidFill>
+                <a:latin typeface="Aptos"/>
+              </a:rPr>
+              <a:t>✓</a:t>
+            </a:r>
+          </a:p>
+        </p:txBody>
+      </p:sp>
+      <p:sp>
+        <p:nvSpPr>
+          <p:cNvPr id="41" name="TextBox 40"/>
+          <p:cNvSpPr txBox="1"/>
+          <p:nvPr/>
+        </p:nvSpPr>
+        <p:spPr>
+          <a:xfrm>
+            <a:off x="4864608" y="2340864"/>
+            <a:ext cx="530352" cy="201168"/>
+          </a:xfrm>
+          <a:prstGeom prst="rect">
+            <a:avLst/>
+          </a:prstGeom>
+          <a:noFill/>
+        </p:spPr>
+        <p:txBody>
+          <a:bodyPr wrap="square">
+            <a:normAutofit/>
+          </a:bodyPr>
+          <a:lstStyle/>
+          <a:p>
+            <a:pPr algn="l"/>
+            <a:r>
+              <a:rPr sz="950" b="1">
+                <a:solidFill>
+                  <a:srgbClr val="E97D37"/>
+                </a:solidFill>
+                <a:latin typeface="Aptos"/>
+              </a:rPr>
+              <a:t>S3</a:t>
+            </a:r>
+          </a:p>
+        </p:txBody>
+      </p:sp>
+      <p:sp>
+        <p:nvSpPr>
+          <p:cNvPr id="42" name="TextBox 41"/>
+          <p:cNvSpPr txBox="1"/>
+          <p:nvPr/>
+        </p:nvSpPr>
+        <p:spPr>
+          <a:xfrm>
+            <a:off x="5440680" y="2340864"/>
+            <a:ext cx="3063240" cy="201168"/>
+          </a:xfrm>
+          <a:prstGeom prst="rect">
+            <a:avLst/>
+          </a:prstGeom>
+          <a:noFill/>
+        </p:spPr>
+        <p:txBody>
+          <a:bodyPr wrap="square">
+            <a:normAutofit/>
+          </a:bodyPr>
+          <a:lstStyle/>
+          <a:p>
+            <a:pPr algn="l"/>
+            <a:r>
+              <a:rPr sz="919" b="0">
+                <a:solidFill>
+                  <a:srgbClr val="16222E"/>
+                </a:solidFill>
+                <a:latin typeface="Aptos"/>
+              </a:rPr>
+              <a:t>Routine engine + historique comportemental</a:t>
+            </a:r>
+          </a:p>
+        </p:txBody>
+      </p:sp>
+      <p:sp>
+        <p:nvSpPr>
+          <p:cNvPr id="43" name="TextBox 42"/>
+          <p:cNvSpPr txBox="1"/>
+          <p:nvPr/>
+        </p:nvSpPr>
+        <p:spPr>
+          <a:xfrm>
+            <a:off x="8458200" y="2340864"/>
+            <a:ext cx="182880" cy="201168"/>
+          </a:xfrm>
+          <a:prstGeom prst="rect">
+            <a:avLst/>
+          </a:prstGeom>
+          <a:noFill/>
+        </p:spPr>
+        <p:txBody>
+          <a:bodyPr wrap="square">
+            <a:normAutofit/>
+          </a:bodyPr>
+          <a:lstStyle/>
+          <a:p>
+            <a:pPr algn="r"/>
+            <a:r>
+              <a:rPr sz="1000" b="1">
+                <a:solidFill>
+                  <a:srgbClr val="0FA569"/>
+                </a:solidFill>
+                <a:latin typeface="Aptos"/>
+              </a:rPr>
+              <a:t>✓</a:t>
+            </a:r>
+          </a:p>
+        </p:txBody>
+      </p:sp>
+      <p:sp>
+        <p:nvSpPr>
+          <p:cNvPr id="44" name="TextBox 43"/>
+          <p:cNvSpPr txBox="1"/>
+          <p:nvPr/>
+        </p:nvSpPr>
+        <p:spPr>
+          <a:xfrm>
+            <a:off x="4864608" y="2734056"/>
+            <a:ext cx="530352" cy="201168"/>
+          </a:xfrm>
+          <a:prstGeom prst="rect">
+            <a:avLst/>
+          </a:prstGeom>
+          <a:noFill/>
+        </p:spPr>
+        <p:txBody>
+          <a:bodyPr wrap="square">
+            <a:normAutofit/>
+          </a:bodyPr>
+          <a:lstStyle/>
+          <a:p>
+            <a:pPr algn="l"/>
+            <a:r>
+              <a:rPr sz="950" b="1">
+                <a:solidFill>
+                  <a:srgbClr val="E97D37"/>
+                </a:solidFill>
+                <a:latin typeface="Aptos"/>
+              </a:rPr>
+              <a:t>S4</a:t>
+            </a:r>
+          </a:p>
+        </p:txBody>
+      </p:sp>
+      <p:sp>
+        <p:nvSpPr>
+          <p:cNvPr id="45" name="TextBox 44"/>
+          <p:cNvSpPr txBox="1"/>
+          <p:nvPr/>
+        </p:nvSpPr>
+        <p:spPr>
+          <a:xfrm>
+            <a:off x="5440680" y="2734056"/>
+            <a:ext cx="3063240" cy="201168"/>
+          </a:xfrm>
+          <a:prstGeom prst="rect">
+            <a:avLst/>
+          </a:prstGeom>
+          <a:noFill/>
+        </p:spPr>
+        <p:txBody>
+          <a:bodyPr wrap="square">
+            <a:normAutofit/>
+          </a:bodyPr>
+          <a:lstStyle/>
+          <a:p>
+            <a:pPr algn="l"/>
+            <a:r>
+              <a:rPr sz="919" b="0">
+                <a:solidFill>
+                  <a:srgbClr val="16222E"/>
+                </a:solidFill>
+                <a:latin typeface="Aptos"/>
+              </a:rPr>
+              <a:t>Escalade et traçabilité des alertes</a:t>
+            </a:r>
+          </a:p>
+        </p:txBody>
+      </p:sp>
+      <p:sp>
+        <p:nvSpPr>
+          <p:cNvPr id="46" name="TextBox 45"/>
+          <p:cNvSpPr txBox="1"/>
+          <p:nvPr/>
+        </p:nvSpPr>
+        <p:spPr>
+          <a:xfrm>
+            <a:off x="8458200" y="2734056"/>
+            <a:ext cx="182880" cy="201168"/>
+          </a:xfrm>
+          <a:prstGeom prst="rect">
+            <a:avLst/>
+          </a:prstGeom>
+          <a:noFill/>
+        </p:spPr>
+        <p:txBody>
+          <a:bodyPr wrap="square">
+            <a:normAutofit/>
+          </a:bodyPr>
+          <a:lstStyle/>
+          <a:p>
+            <a:pPr algn="r"/>
+            <a:r>
+              <a:rPr sz="1000" b="1">
+                <a:solidFill>
+                  <a:srgbClr val="0FA569"/>
+                </a:solidFill>
+                <a:latin typeface="Aptos"/>
+              </a:rPr>
+              <a:t>✓</a:t>
+            </a:r>
+          </a:p>
+        </p:txBody>
+      </p:sp>
+      <p:sp>
+        <p:nvSpPr>
+          <p:cNvPr id="47" name="TextBox 46"/>
+          <p:cNvSpPr txBox="1"/>
+          <p:nvPr/>
+        </p:nvSpPr>
+        <p:spPr>
+          <a:xfrm>
+            <a:off x="4864608" y="3127248"/>
+            <a:ext cx="530352" cy="201168"/>
+          </a:xfrm>
+          <a:prstGeom prst="rect">
+            <a:avLst/>
+          </a:prstGeom>
+          <a:noFill/>
+        </p:spPr>
+        <p:txBody>
+          <a:bodyPr wrap="square">
+            <a:normAutofit/>
+          </a:bodyPr>
+          <a:lstStyle/>
+          <a:p>
+            <a:pPr algn="l"/>
+            <a:r>
+              <a:rPr sz="950" b="1">
+                <a:solidFill>
+                  <a:srgbClr val="E97D37"/>
+                </a:solidFill>
+                <a:latin typeface="Aptos"/>
+              </a:rPr>
+              <a:t>S5</a:t>
+            </a:r>
+          </a:p>
+        </p:txBody>
+      </p:sp>
+      <p:sp>
+        <p:nvSpPr>
+          <p:cNvPr id="48" name="TextBox 47"/>
+          <p:cNvSpPr txBox="1"/>
+          <p:nvPr/>
+        </p:nvSpPr>
+        <p:spPr>
+          <a:xfrm>
+            <a:off x="5440680" y="3127248"/>
+            <a:ext cx="3063240" cy="201168"/>
+          </a:xfrm>
+          <a:prstGeom prst="rect">
+            <a:avLst/>
+          </a:prstGeom>
+          <a:noFill/>
+        </p:spPr>
+        <p:txBody>
+          <a:bodyPr wrap="square">
+            <a:normAutofit/>
+          </a:bodyPr>
+          <a:lstStyle/>
+          <a:p>
+            <a:pPr algn="l"/>
+            <a:r>
+              <a:rPr sz="919" b="0">
+                <a:solidFill>
+                  <a:srgbClr val="16222E"/>
+                </a:solidFill>
+                <a:latin typeface="Aptos"/>
+              </a:rPr>
+              <a:t>Soignant assigné + notifications ciblées</a:t>
+            </a:r>
+          </a:p>
+        </p:txBody>
+      </p:sp>
+      <p:sp>
+        <p:nvSpPr>
+          <p:cNvPr id="49" name="TextBox 48"/>
+          <p:cNvSpPr txBox="1"/>
+          <p:nvPr/>
+        </p:nvSpPr>
+        <p:spPr>
+          <a:xfrm>
+            <a:off x="8458200" y="3127248"/>
+            <a:ext cx="182880" cy="201168"/>
+          </a:xfrm>
+          <a:prstGeom prst="rect">
+            <a:avLst/>
+          </a:prstGeom>
+          <a:noFill/>
+        </p:spPr>
+        <p:txBody>
+          <a:bodyPr wrap="square">
+            <a:normAutofit/>
+          </a:bodyPr>
+          <a:lstStyle/>
+          <a:p>
+            <a:pPr algn="r"/>
+            <a:r>
+              <a:rPr sz="1000" b="1">
+                <a:solidFill>
+                  <a:srgbClr val="0FA569"/>
+                </a:solidFill>
+                <a:latin typeface="Aptos"/>
+              </a:rPr>
+              <a:t>✓</a:t>
+            </a:r>
+          </a:p>
+        </p:txBody>
+      </p:sp>
+      <p:sp>
+        <p:nvSpPr>
+          <p:cNvPr id="50" name="TextBox 49"/>
+          <p:cNvSpPr txBox="1"/>
+          <p:nvPr/>
+        </p:nvSpPr>
+        <p:spPr>
+          <a:xfrm>
+            <a:off x="4864608" y="3520440"/>
+            <a:ext cx="530352" cy="201168"/>
+          </a:xfrm>
+          <a:prstGeom prst="rect">
+            <a:avLst/>
+          </a:prstGeom>
+          <a:noFill/>
+        </p:spPr>
+        <p:txBody>
+          <a:bodyPr wrap="square">
+            <a:normAutofit/>
+          </a:bodyPr>
+          <a:lstStyle/>
+          <a:p>
+            <a:pPr algn="l"/>
+            <a:r>
+              <a:rPr sz="950" b="1">
+                <a:solidFill>
+                  <a:srgbClr val="E97D37"/>
+                </a:solidFill>
+                <a:latin typeface="Aptos"/>
+              </a:rPr>
+              <a:t>C2/C3</a:t>
+            </a:r>
+          </a:p>
+        </p:txBody>
+      </p:sp>
+      <p:sp>
+        <p:nvSpPr>
+          <p:cNvPr id="51" name="TextBox 50"/>
+          <p:cNvSpPr txBox="1"/>
+          <p:nvPr/>
+        </p:nvSpPr>
+        <p:spPr>
+          <a:xfrm>
+            <a:off x="5440680" y="3520440"/>
+            <a:ext cx="3063240" cy="201168"/>
+          </a:xfrm>
+          <a:prstGeom prst="rect">
+            <a:avLst/>
+          </a:prstGeom>
+          <a:noFill/>
+        </p:spPr>
+        <p:txBody>
+          <a:bodyPr wrap="square">
+            <a:normAutofit/>
+          </a:bodyPr>
+          <a:lstStyle/>
+          <a:p>
+            <a:pPr algn="l"/>
+            <a:r>
+              <a:rPr sz="919" b="0">
+                <a:solidFill>
+                  <a:srgbClr val="16222E"/>
+                </a:solidFill>
+                <a:latin typeface="Aptos"/>
+              </a:rPr>
+              <a:t>Rapport LLM quotidien + portail famille RGPD</a:t>
+            </a:r>
+          </a:p>
+        </p:txBody>
+      </p:sp>
+      <p:sp>
+        <p:nvSpPr>
+          <p:cNvPr id="52" name="TextBox 51"/>
+          <p:cNvSpPr txBox="1"/>
+          <p:nvPr/>
+        </p:nvSpPr>
+        <p:spPr>
+          <a:xfrm>
+            <a:off x="8458200" y="3520440"/>
+            <a:ext cx="182880" cy="201168"/>
+          </a:xfrm>
+          <a:prstGeom prst="rect">
+            <a:avLst/>
+          </a:prstGeom>
+          <a:noFill/>
+        </p:spPr>
+        <p:txBody>
+          <a:bodyPr wrap="square">
+            <a:normAutofit/>
+          </a:bodyPr>
+          <a:lstStyle/>
+          <a:p>
+            <a:pPr algn="r"/>
+            <a:r>
+              <a:rPr sz="1000" b="1">
+                <a:solidFill>
+                  <a:srgbClr val="0FA569"/>
+                </a:solidFill>
+                <a:latin typeface="Aptos"/>
+              </a:rPr>
+              <a:t>✓</a:t>
+            </a:r>
+          </a:p>
+        </p:txBody>
+      </p:sp>
+      <p:sp>
+        <p:nvSpPr>
+          <p:cNvPr id="53" name="TextBox 52"/>
+          <p:cNvSpPr txBox="1"/>
+          <p:nvPr/>
+        </p:nvSpPr>
+        <p:spPr>
+          <a:xfrm>
+            <a:off x="4864608" y="3913632"/>
+            <a:ext cx="530352" cy="201168"/>
+          </a:xfrm>
+          <a:prstGeom prst="rect">
+            <a:avLst/>
+          </a:prstGeom>
+          <a:noFill/>
+        </p:spPr>
+        <p:txBody>
+          <a:bodyPr wrap="square">
+            <a:normAutofit/>
+          </a:bodyPr>
+          <a:lstStyle/>
+          <a:p>
+            <a:pPr algn="l"/>
+            <a:r>
+              <a:rPr sz="950" b="1">
+                <a:solidFill>
+                  <a:srgbClr val="E97D37"/>
+                </a:solidFill>
+                <a:latin typeface="Aptos"/>
+              </a:rPr>
+              <a:t>C1/C4/C5</a:t>
+            </a:r>
+          </a:p>
+        </p:txBody>
+      </p:sp>
+      <p:sp>
+        <p:nvSpPr>
+          <p:cNvPr id="54" name="TextBox 53"/>
+          <p:cNvSpPr txBox="1"/>
+          <p:nvPr/>
+        </p:nvSpPr>
+        <p:spPr>
+          <a:xfrm>
+            <a:off x="5440680" y="3913632"/>
+            <a:ext cx="3063240" cy="201168"/>
+          </a:xfrm>
+          <a:prstGeom prst="rect">
+            <a:avLst/>
+          </a:prstGeom>
+          <a:noFill/>
+        </p:spPr>
+        <p:txBody>
+          <a:bodyPr wrap="square">
+            <a:normAutofit/>
+          </a:bodyPr>
+          <a:lstStyle/>
+          <a:p>
+            <a:pPr algn="l"/>
+            <a:r>
+              <a:rPr sz="919" b="0">
+                <a:solidFill>
+                  <a:srgbClr val="16222E"/>
+                </a:solidFill>
+                <a:latin typeface="Aptos"/>
+              </a:rPr>
+              <a:t>Fugue, routine, tests automatisés</a:t>
+            </a:r>
+          </a:p>
+        </p:txBody>
+      </p:sp>
+      <p:sp>
+        <p:nvSpPr>
+          <p:cNvPr id="55" name="TextBox 54"/>
+          <p:cNvSpPr txBox="1"/>
+          <p:nvPr/>
+        </p:nvSpPr>
+        <p:spPr>
+          <a:xfrm>
+            <a:off x="8458200" y="3913632"/>
+            <a:ext cx="182880" cy="201168"/>
+          </a:xfrm>
+          <a:prstGeom prst="rect">
+            <a:avLst/>
+          </a:prstGeom>
+          <a:noFill/>
+        </p:spPr>
+        <p:txBody>
+          <a:bodyPr wrap="square">
+            <a:normAutofit/>
+          </a:bodyPr>
+          <a:lstStyle/>
+          <a:p>
+            <a:pPr algn="r"/>
+            <a:r>
+              <a:rPr sz="1000" b="1">
+                <a:solidFill>
+                  <a:srgbClr val="0FA569"/>
+                </a:solidFill>
+                <a:latin typeface="Aptos"/>
+              </a:rPr>
+              <a:t>✓</a:t>
+            </a:r>
+          </a:p>
+        </p:txBody>
+      </p:sp>
+      <p:sp>
+        <p:nvSpPr>
+          <p:cNvPr id="56" name="Rectangle 55"/>
+          <p:cNvSpPr/>
+          <p:nvPr/>
+        </p:nvSpPr>
+        <p:spPr>
+          <a:xfrm>
+            <a:off x="320040" y="4736592"/>
+            <a:ext cx="8503920" cy="228600"/>
+          </a:xfrm>
+          <a:prstGeom prst="rect">
+            <a:avLst/>
+          </a:prstGeom>
+          <a:solidFill>
+            <a:srgbClr val="EBF8FA"/>
+          </a:solidFill>
+          <a:ln>
+            <a:noFill/>
+          </a:ln>
+        </p:spPr>
+        <p:style>
+          <a:lnRef idx="1">
+            <a:schemeClr val="accent1"/>
+          </a:lnRef>
+          <a:fillRef idx="3">
+            <a:schemeClr val="accent1"/>
+          </a:fillRef>
+          <a:effectRef idx="2">
+            <a:schemeClr val="accent1"/>
+          </a:effectRef>
+          <a:fontRef idx="minor">
+            <a:schemeClr val="lt1"/>
+          </a:fontRef>
+        </p:style>
+        <p:txBody>
+          <a:bodyPr rtlCol="0" anchor="ctr"/>
+          <a:lstStyle/>
+          <a:p>
+            <a:pPr algn="ctr"/>
+            <a:endParaRPr/>
+          </a:p>
+        </p:txBody>
+      </p:sp>
+      <p:sp>
+        <p:nvSpPr>
+          <p:cNvPr id="57" name="TextBox 56"/>
+          <p:cNvSpPr txBox="1"/>
+          <p:nvPr/>
+        </p:nvSpPr>
+        <p:spPr>
+          <a:xfrm>
+            <a:off x="475488" y="4773168"/>
+            <a:ext cx="8183879" cy="155448"/>
+          </a:xfrm>
+          <a:prstGeom prst="rect">
+            <a:avLst/>
+          </a:prstGeom>
+          <a:noFill/>
+        </p:spPr>
+        <p:txBody>
+          <a:bodyPr wrap="square">
+            <a:normAutofit/>
+          </a:bodyPr>
+          <a:lstStyle/>
+          <a:p>
+            <a:pPr algn="l"/>
+            <a:r>
+              <a:rPr sz="869" b="0">
+                <a:solidFill>
+                  <a:srgbClr val="00747E"/>
+                </a:solidFill>
+                <a:latin typeface="Aptos"/>
+              </a:rPr>
+              <a:t>Point d’attention à dire à l’oral : démo locale sécurisée par comptes/ACL ; TLS MQTT 8883 est une évolution production, pas activée dans le Compose actuel.</a:t>
+            </a:r>
+          </a:p>
+        </p:txBody>
+      </p:sp>
     </p:spTree>
   </p:cSld>
   <p:clrMapOvr>
@@ -12044,7 +14079,7 @@
                 <a:ea typeface="Calibri" pitchFamily="34" charset="-122"/>
                 <a:cs typeface="Calibri" pitchFamily="34" charset="-120"/>
               </a:rPr>
-              <a:t>Pipeline MQTT → FastAPI → 7 agents A2A → 3 LLM routés. Alertes 5 niveaux NEWS2, prédiction 30-60 min, rapport LLM quotidien, espace famille RGPD.</a:t>
+              <a:t>Pipeline MQTT → FastAPI → 7 agents A2A → LLM optionnel. Alertes 5 niveaux NEWS2, prédiction 30-60 min, rapport LLM quotidien, espace famille RGPD.</a:t>
             </a:r>
             <a:endParaRPr lang="en-US" sz="1100" dirty="0"/>
           </a:p>
@@ -12617,7 +14652,7 @@
                 <a:ea typeface="Calibri" pitchFamily="34" charset="-122"/>
                 <a:cs typeface="Calibri" pitchFamily="34" charset="-120"/>
               </a:rPr>
-              <a:t>Auth + TLS 1.3 · ACL</a:t>
+              <a:t>Auth + ACL</a:t>
             </a:r>
             <a:endParaRPr lang="en-US" sz="800" dirty="0"/>
           </a:p>
@@ -12894,7 +14929,7 @@
                 <a:ea typeface="Calibri" pitchFamily="34" charset="-122"/>
                 <a:cs typeface="Calibri" pitchFamily="34" charset="-120"/>
               </a:rPr>
-              <a:t>React</a:t>
+              <a:t>HTML/JS</a:t>
             </a:r>
             <a:endParaRPr lang="en-US" sz="1000" dirty="0"/>
           </a:p>
@@ -13958,7 +15993,7 @@
                 <a:ea typeface="Calibri" pitchFamily="34" charset="-122"/>
                 <a:cs typeface="Calibri" pitchFamily="34" charset="-120"/>
               </a:rPr>
-              <a:t>3 LLM locaux</a:t>
+              <a:t>Optionnel</a:t>
             </a:r>
             <a:endParaRPr lang="en-US" sz="850" dirty="0"/>
           </a:p>
@@ -14208,7 +16243,7 @@
                 <a:ea typeface="Calibri" pitchFamily="34" charset="-122"/>
                 <a:cs typeface="Calibri" pitchFamily="34" charset="-120"/>
               </a:rPr>
-              <a:t>🐳  docker compose up --build   ·   8 services   ·   stack complète en une commande</a:t>
+              <a:t>🐳  docker compose up --build -d · 7 services Compose + Ollama optionnel · stack complète</a:t>
             </a:r>
             <a:endParaRPr lang="en-US" sz="1000" dirty="0"/>
           </a:p>
@@ -15725,7 +17760,7 @@
                 <a:ea typeface="Calibri" pitchFamily="34" charset="-122"/>
                 <a:cs typeface="Calibri" pitchFamily="34" charset="-120"/>
               </a:rPr>
-              <a:t>TLS 1.3 · allow_anonymous false · ACL par rôle · passwd bcrypt · port 8883</a:t>
+              <a:t>Comptes MQTT · allow_anonymous false · ACL par rôle · passwd bcrypt · ports 1883/9001 locaux</a:t>
             </a:r>
             <a:endParaRPr lang="en-US" sz="950" dirty="0"/>
           </a:p>
@@ -15937,7 +17972,7 @@
                 <a:ea typeface="Calibri" pitchFamily="34" charset="-122"/>
                 <a:cs typeface="Calibri" pitchFamily="34" charset="-120"/>
               </a:rPr>
-              <a:t>7 agents A2A · NEWS2 · ML GradientBoost · 3 LLM routés · Redis async · APIRouter</a:t>
+              <a:t>7 agents A2A · NEWS2 · ML GradientBoost · LLM optionnel · Redis + APIRouter</a:t>
             </a:r>
             <a:endParaRPr lang="en-US" sz="950" dirty="0"/>
           </a:p>
@@ -16322,7 +18357,7 @@
                 <a:ea typeface="Calibri" pitchFamily="34" charset="-122"/>
                 <a:cs typeface="Calibri" pitchFamily="34" charset="-120"/>
               </a:rPr>
-              <a:t>React + Vite</a:t>
+              <a:t>HTML/CSS/JS + Express</a:t>
             </a:r>
             <a:endParaRPr lang="en-US" sz="1000" dirty="0"/>
           </a:p>
@@ -16534,7 +18569,7 @@
                 <a:ea typeface="Calibri" pitchFamily="34" charset="-122"/>
                 <a:cs typeface="Calibri" pitchFamily="34" charset="-120"/>
               </a:rPr>
-              <a:t>3 LLM + GradientBoost</a:t>
+              <a:t>GradientBoost + LLM optionnel</a:t>
             </a:r>
             <a:endParaRPr lang="en-US" sz="1000" dirty="0"/>
           </a:p>
@@ -16573,7 +18608,7 @@
                 <a:ea typeface="Calibri" pitchFamily="34" charset="-122"/>
                 <a:cs typeface="Calibri" pitchFamily="34" charset="-120"/>
               </a:rPr>
-              <a:t>Llama 3.2 3B (résumés rapides) · Qwen 2.5 7B (JSON structuré) · Meditron 7B (rapport quotidien)</a:t>
+              <a:t>Scikit-learn / GradientBoost pour risque 30-60 min · Ollama local optionnel pour synthèses et rapports</a:t>
             </a:r>
             <a:endParaRPr lang="en-US" sz="950" dirty="0"/>
           </a:p>
@@ -17983,7 +20018,7 @@
                 <a:ea typeface="Calibri" pitchFamily="34" charset="-122"/>
                 <a:cs typeface="Calibri" pitchFamily="34" charset="-120"/>
               </a:rPr>
-              <a:t>+ LLM</a:t>
+              <a:t>+ ML/LLM</a:t>
             </a:r>
             <a:endParaRPr lang="en-US" sz="1000" dirty="0"/>
           </a:p>
@@ -18039,7 +20074,7 @@
                 <a:ea typeface="Calibri" pitchFamily="34" charset="-122"/>
                 <a:cs typeface="Calibri" pitchFamily="34" charset="-120"/>
               </a:rPr>
-              <a:t>3 modèles routés</a:t>
+              <a:t>LLM optionnel</a:t>
             </a:r>
             <a:endParaRPr lang="en-US" sz="850" dirty="0"/>
           </a:p>
@@ -21223,7 +23258,7 @@
                 <a:ea typeface="Calibri" pitchFamily="34" charset="-122"/>
                 <a:cs typeface="Calibri" pitchFamily="34" charset="-120"/>
               </a:rPr>
-              <a:t>Routing LLM — 3 Modèles, 3 Responsabilités</a:t>
+              <a:t>LLM local optionnel — 3 usages possibles</a:t>
             </a:r>
             <a:endParaRPr lang="en-US" sz="1700" dirty="0"/>
           </a:p>
@@ -21389,7 +23424,7 @@
                 <a:ea typeface="Calibri" pitchFamily="34" charset="-122"/>
                 <a:cs typeface="Calibri" pitchFamily="34" charset="-120"/>
               </a:rPr>
-              <a:t>Agent Synthèse (A2A) décide la tâche → LLM Router → modèle optimal</a:t>
+              <a:t>Agent Synthèse prépare le contexte → Ollama local optionnel → résumé / JSON / rapport</a:t>
             </a:r>
             <a:endParaRPr lang="en-US" sz="1100" dirty="0"/>
           </a:p>
@@ -23559,7 +25594,7 @@
                 <a:ea typeface="Calibri" pitchFamily="34" charset="-122"/>
                 <a:cs typeface="Calibri" pitchFamily="34" charset="-120"/>
               </a:rPr>
-              <a:t>✓  Après — Sécurisé TLS 1.3 + ACL</a:t>
+              <a:t>✓  Après — Sécurisé par comptes + ACL</a:t>
             </a:r>
             <a:endParaRPr lang="en-US" sz="1000" dirty="0"/>
           </a:p>
@@ -23586,78 +25621,67 @@
           <a:bodyPr wrap="square" lIns="0" tIns="0" rIns="0" bIns="0" rtlCol="0" anchor="ctr"/>
           <a:lstStyle/>
           <a:p>
-            <a:pPr marL="0" indent="0">
-              <a:buNone/>
-            </a:pPr>
-            <a:r>
-              <a:rPr lang="en-US" sz="900" dirty="0">
-                <a:solidFill>
-                  <a:srgbClr val="334155"/>
-                </a:solidFill>
-                <a:latin typeface="Calibri" pitchFamily="34" charset="0"/>
-                <a:ea typeface="Calibri" pitchFamily="34" charset="-122"/>
-                <a:cs typeface="Calibri" pitchFamily="34" charset="-120"/>
+            <a:r>
+              <a:rPr sz="1100">
+                <a:solidFill>
+                  <a:srgbClr val="2C3E50"/>
+                </a:solidFill>
+                <a:latin typeface="Aptos"/>
               </a:rPr>
               <a:t>allow_anonymous false · password_file bcrypt</a:t>
             </a:r>
-            <a:endParaRPr lang="en-US" sz="900" dirty="0"/>
-          </a:p>
-          <a:p>
-            <a:pPr marL="0" indent="0">
-              <a:buNone/>
-            </a:pPr>
-            <a:r>
-              <a:rPr lang="en-US" sz="900" dirty="0">
-                <a:solidFill>
-                  <a:srgbClr val="334155"/>
-                </a:solidFill>
-                <a:latin typeface="Calibri" pitchFamily="34" charset="0"/>
-                <a:ea typeface="Calibri" pitchFamily="34" charset="-122"/>
-                <a:cs typeface="Calibri" pitchFamily="34" charset="-120"/>
-              </a:rPr>
-              <a:t>listener 8883 · TLS 1.3 · acl_file par rôle</a:t>
-            </a:r>
-            <a:endParaRPr lang="en-US" sz="900" dirty="0"/>
-          </a:p>
-          <a:p>
-            <a:pPr marL="0" indent="0">
-              <a:buNone/>
-            </a:pPr>
-            <a:endParaRPr lang="en-US" sz="900" dirty="0"/>
-          </a:p>
-          <a:p>
-            <a:pPr marL="0" indent="0">
-              <a:buNone/>
-            </a:pPr>
-            <a:r>
-              <a:rPr lang="en-US" sz="900" dirty="0">
-                <a:solidFill>
-                  <a:srgbClr val="334155"/>
-                </a:solidFill>
-                <a:latin typeface="Calibri" pitchFamily="34" charset="0"/>
-                <a:ea typeface="Calibri" pitchFamily="34" charset="-122"/>
-                <a:cs typeface="Calibri" pitchFamily="34" charset="-120"/>
-              </a:rPr>
-              <a:t>simulator → write ehpad/residents/# uniquement</a:t>
-            </a:r>
-            <a:endParaRPr lang="en-US" sz="900" dirty="0"/>
-          </a:p>
-          <a:p>
-            <a:pPr marL="0" indent="0">
-              <a:buNone/>
-            </a:pPr>
-            <a:r>
-              <a:rPr lang="en-US" sz="900" dirty="0">
-                <a:solidFill>
-                  <a:srgbClr val="334155"/>
-                </a:solidFill>
-                <a:latin typeface="Calibri" pitchFamily="34" charset="0"/>
-                <a:ea typeface="Calibri" pitchFamily="34" charset="-122"/>
-                <a:cs typeface="Calibri" pitchFamily="34" charset="-120"/>
+          </a:p>
+          <a:p>
+            <a:r>
+              <a:rPr sz="1100">
+                <a:solidFill>
+                  <a:srgbClr val="2C3E50"/>
+                </a:solidFill>
+                <a:latin typeface="Aptos"/>
+              </a:rPr>
+              <a:t>listeners 1883/9001 locaux · acl_file par rôle</a:t>
+            </a:r>
+          </a:p>
+          <a:p>
+            <a:endParaRPr sz="1100">
+              <a:solidFill>
+                <a:srgbClr val="2C3E50"/>
+              </a:solidFill>
+              <a:latin typeface="Aptos"/>
+            </a:endParaRPr>
+          </a:p>
+          <a:p>
+            <a:r>
+              <a:rPr sz="1100">
+                <a:solidFill>
+                  <a:srgbClr val="2C3E50"/>
+                </a:solidFill>
+                <a:latin typeface="Aptos"/>
+              </a:rPr>
+              <a:t>simulator → write ehpad/residents/# et zones/#</a:t>
+            </a:r>
+          </a:p>
+          <a:p>
+            <a:r>
+              <a:rPr sz="1100">
+                <a:solidFill>
+                  <a:srgbClr val="2C3E50"/>
+                </a:solidFill>
+                <a:latin typeface="Aptos"/>
               </a:rPr>
               <a:t>backend → read ehpad/# + write control/#</a:t>
             </a:r>
-            <a:endParaRPr lang="en-US" sz="900" dirty="0"/>
+          </a:p>
+          <a:p>
+            <a:r>
+              <a:rPr sz="1100">
+                <a:solidFill>
+                  <a:srgbClr val="2C3E50"/>
+                </a:solidFill>
+                <a:latin typeface="Aptos"/>
+              </a:rPr>
+              <a:t>TLS 8883 = évolution production</a:t>
+            </a:r>
           </a:p>
         </p:txBody>
       </p:sp>
@@ -25717,7 +27741,7 @@
                 <a:ea typeface="Calibri" pitchFamily="34" charset="-122"/>
                 <a:cs typeface="Calibri" pitchFamily="34" charset="-120"/>
               </a:rPr>
-              <a:t>Qwen 2.5 7B : hypothèses JSON. Llama 3.2 3B : résumé soignant en 2s. Famille : message bienveillant</a:t>
+              <a:t>LLM local optionnel : hypothèses JSON, résumé soignant, message famille bienveillant</a:t>
             </a:r>
             <a:endParaRPr lang="en-US" sz="950" dirty="0"/>
           </a:p>
@@ -25937,7 +27961,7 @@
                 <a:ea typeface="Calibri" pitchFamily="34" charset="-122"/>
                 <a:cs typeface="Calibri" pitchFamily="34" charset="-120"/>
               </a:rPr>
-              <a:t>Meditron 7B : rapport complet à minuit · contexte A2A pré-calculé injecté · fiche transmission PDF</a:t>
+              <a:t>Rapport quotidien optionnel : contexte A2A pré-calculé · fiche transmission PDF</a:t>
             </a:r>
             <a:endParaRPr lang="en-US" sz="950" dirty="0"/>
           </a:p>
@@ -26008,7 +28032,7 @@
                 <a:ea typeface="Calibri" pitchFamily="34" charset="-122"/>
                 <a:cs typeface="Calibri" pitchFamily="34" charset="-120"/>
               </a:rPr>
-              <a:t>$ docker compose up --build   →   stack complète · 8 services · ouvrir http://localhost:3002</a:t>
+              <a:t>$ docker compose up --build   →   stack complète · 7 services Compose · ouvrir http://localhost:3002</a:t>
             </a:r>
             <a:endParaRPr lang="en-US" sz="1000" dirty="0"/>
           </a:p>

</xml_diff>